<commit_message>
Add clinical utility analysis functions and tests for glycemic variability data
- Implement functions for calibration curves, decision curves, Platt recalibration, and subgroup analysis in `twin/eval/clinical.py`.
- Create a loader for BIG IDEAs Lab data, including RMSSD calculation from beat intervals in `twin/ingest/bigideas.py`.
- Add unit tests for the new clinical utility functions in `tests/test_clinical.py`.
</commit_message>
<xml_diff>
--- a/docs/architecture.pptx
+++ b/docs/architecture.pptx
@@ -1459,7 +1459,7 @@
                 <a:ea typeface="Calibri" pitchFamily="34" charset="-122"/>
                 <a:cs typeface="Calibri" pitchFamily="34" charset="-120"/>
               </a:rPr>
-              <a:t>Synthetic India cohort 1,000 × 14 d · CGMacros (45, real) · ShanghaiT2DM (100, external)</a:t>
+              <a:t>Synthetic India cohort 1,000 × 14 d · CGMacros (45, real) · BIG IDEAs (16, real HRV) · ShanghaiT2DM (100, external)</a:t>
             </a:r>
             <a:endParaRPr lang="en-US" sz="1100" dirty="0"/>
           </a:p>
@@ -2014,7 +2014,7 @@
                 <a:ea typeface="Calibri" pitchFamily="34" charset="-122"/>
                 <a:cs typeface="Calibri" pitchFamily="34" charset="-120"/>
               </a:rPr>
-              <a:t>LightGBM + SHAP: plain-language reasons</a:t>
+              <a:t>Fine-tuned per person, averaged with LightGBM; SHAP reasons</a:t>
             </a:r>
             <a:endParaRPr lang="en-US" sz="1300" dirty="0"/>
           </a:p>
@@ -2614,47 +2614,47 @@
 </file>
 
 <file path=ppt/theme/theme1.xml><?xml version="1.0" encoding="utf-8"?>
-<a:theme xmlns:a="http://schemas.openxmlformats.org/drawingml/2006/main" name="MadhuTwin">
+<a:theme xmlns:a="http://schemas.openxmlformats.org/drawingml/2006/main" name="Office Theme">
   <a:themeElements>
-    <a:clrScheme name="MadhuTwin">
+    <a:clrScheme name="Office">
       <a:dk1>
-        <a:srgbClr val="16181D"/>
+        <a:sysClr val="windowText" lastClr="000000"/>
       </a:dk1>
       <a:lt1>
-        <a:srgbClr val="FFFFFF"/>
+        <a:sysClr val="window" lastClr="FFFFFF"/>
       </a:lt1>
       <a:dk2>
-        <a:srgbClr val="14284B"/>
+        <a:srgbClr val="44546A"/>
       </a:dk2>
       <a:lt2>
-        <a:srgbClr val="EEF2F8"/>
+        <a:srgbClr val="E7E6E6"/>
       </a:lt2>
       <a:accent1>
-        <a:srgbClr val="2A78D6"/>
+        <a:srgbClr val="4472C4"/>
       </a:accent1>
       <a:accent2>
-        <a:srgbClr val="EB6834"/>
+        <a:srgbClr val="ED7D31"/>
       </a:accent2>
       <a:accent3>
-        <a:srgbClr val="1BAF7A"/>
+        <a:srgbClr val="A5A5A5"/>
       </a:accent3>
       <a:accent4>
-        <a:srgbClr val="E8A317"/>
+        <a:srgbClr val="FFC000"/>
       </a:accent4>
       <a:accent5>
-        <a:srgbClr val="6B5FD3"/>
+        <a:srgbClr val="5B9BD5"/>
       </a:accent5>
       <a:accent6>
-        <a:srgbClr val="D03B3B"/>
+        <a:srgbClr val="70AD47"/>
       </a:accent6>
       <a:hlink>
-        <a:srgbClr val="2A78D6"/>
+        <a:srgbClr val="0563C1"/>
       </a:hlink>
       <a:folHlink>
-        <a:srgbClr val="6B5FD3"/>
+        <a:srgbClr val="954F72"/>
       </a:folHlink>
     </a:clrScheme>
-    <a:fontScheme name="MadhuTwin">
+    <a:fontScheme name="Office">
       <a:majorFont>
         <a:latin typeface="Cambria"/>
         <a:ea typeface=""/>

</xml_diff>